<commit_message>
feature: Phase F｜Metadata ／ OGP ／ SEO（Brand Architecture を検索 ・ シェアまで）
- meta description ／ og:description の旧名称を現行名へ（LP は「Dreamin' Spiral 🌱 の Service Name。」＋ Hero の文）
- og:title：6 Service の LP は `Dreamin' Spiral 🌱 | Service Name`（§1.3 B）。Browser title は `ページ名 | B8E` のまま（Terms だけ見出しに合わせる）
- og:image：Brand OGP System に Home ＋ 6 Service のスライド（Slide 14〜20）と PNG 7 枚
- og:site_name ・ twitter:card を対象ページへ
- sitemap.xml ／ robots.txt を新設（index 対象の公開 19 ページのみ）
- Project Creation Complete の description の転記ミスを修正
- URL ・ form_type ・ metadata.service ・ 本文 ・ Legal の条件は変更なし

Co-Authored-By: Claude Opus 5.5 <noreply@anthropic.com>
</commit_message>
<xml_diff>
--- a/assets/ogp/master/OGP_Template_Master.pptx
+++ b/assets/ogp/master/OGP_Template_Master.pptx
@@ -18,6 +18,13 @@
     <p:sldId id="266" r:id="rId17"/>
     <p:sldId id="267" r:id="rId18"/>
     <p:sldId id="268" r:id="rId19"/>
+    <p:sldId id="269" r:id="rId20"/>
+    <p:sldId id="270" r:id="rId21"/>
+    <p:sldId id="271" r:id="rId22"/>
+    <p:sldId id="272" r:id="rId23"/>
+    <p:sldId id="273" r:id="rId24"/>
+    <p:sldId id="274" r:id="rId25"/>
+    <p:sldId id="275" r:id="rId26"/>
   </p:sldIdLst>
   <p:notesMasterIdLst>
     <p:notesMasterId r:id="rId12"/>
@@ -2902,6 +2909,888 @@
 </p:sld>
 </file>
 
+<file path=ppt/slides/slide14.xml><?xml version="1.0" encoding="utf-8"?>
+<p:sld xmlns:a="http://schemas.openxmlformats.org/drawingml/2006/main" xmlns:p="http://schemas.openxmlformats.org/presentationml/2006/main" xmlns:r="http://schemas.openxmlformats.org/officeDocument/2006/relationships">
+  <p:cSld name="dreamin-spiral-home">
+    <p:spTree>
+      <p:nvGrpSpPr>
+        <p:cNvPr id="1" name=""/>
+        <p:cNvGrpSpPr/>
+        <p:nvPr/>
+      </p:nvGrpSpPr>
+      <p:grpSpPr/>
+      <p:sp>
+        <p:nvSpPr>
+          <p:cNvPr id="2" name="Text 5"/>
+          <p:cNvSpPr/>
+          <p:nvPr>
+            <p:ph idx="105" type="body" hasCustomPrompt="1"/>
+          </p:nvPr>
+        </p:nvSpPr>
+        <p:spPr>
+          <a:xfrm>
+            <a:off x="857250" y="1677924"/>
+            <a:ext cx="9715500" cy="256032"/>
+          </a:xfrm>
+          <a:prstGeom prst="rect">
+            <a:avLst/>
+          </a:prstGeom>
+          <a:noFill/>
+          <a:ln/>
+        </p:spPr>
+        <p:txBody>
+          <a:bodyPr wrap="square" lIns="0" tIns="0" rIns="0" bIns="0" rtlCol="0" anchor="ctr"/>
+          <a:lstStyle/>
+          <a:p>
+            <a:pPr algn="ctr" indent="0" marL="0">
+              <a:buNone/>
+            </a:pPr>
+            <a:r>
+              <a:rPr lang="en-US" sz="1200" spc="250" kern="0" dirty="0">
+                <a:solidFill>
+                  <a:srgbClr val="C0B8AD"/>
+                </a:solidFill>
+                <a:latin typeface="Noto Sans JP" pitchFamily="34" charset="0"/>
+                <a:ea typeface="Noto Sans JP" pitchFamily="34" charset="-122"/>
+                <a:cs typeface="Noto Sans JP" pitchFamily="34" charset="-120"/>
+              </a:rPr>
+              <a:t>DREAMIN' SPIRAL 🌱</a:t>
+            </a:r>
+            <a:endParaRPr lang="en-US" sz="1200" dirty="0"/>
+          </a:p>
+        </p:txBody>
+      </p:sp>
+      <p:sp>
+        <p:nvSpPr>
+          <p:cNvPr id="3" name="Text 5"/>
+          <p:cNvSpPr/>
+          <p:nvPr>
+            <p:ph idx="106" type="title" hasCustomPrompt="1"/>
+          </p:nvPr>
+        </p:nvSpPr>
+        <p:spPr>
+          <a:xfrm>
+            <a:off x="857250" y="2467356"/>
+            <a:ext cx="9715500" cy="960120"/>
+          </a:xfrm>
+          <a:prstGeom prst="rect">
+            <a:avLst/>
+          </a:prstGeom>
+          <a:noFill/>
+          <a:ln/>
+        </p:spPr>
+        <p:txBody>
+          <a:bodyPr wrap="square" lIns="0" tIns="0" rIns="0" bIns="0" rtlCol="0" anchor="ctr"/>
+          <a:lstStyle/>
+          <a:p>
+            <a:pPr algn="ctr" indent="0" marL="0">
+              <a:buNone/>
+            </a:pPr>
+            <a:r>
+              <a:rPr lang="en-US" sz="6600" dirty="0">
+                <a:solidFill>
+                  <a:srgbClr val="F7F6F4"/>
+                </a:solidFill>
+                <a:latin typeface="Noto Sans JP" pitchFamily="34" charset="0"/>
+                <a:ea typeface="Noto Sans JP" pitchFamily="34" charset="-122"/>
+                <a:cs typeface="Noto Sans JP" pitchFamily="34" charset="-120"/>
+              </a:rPr>
+              <a:t>Dreamin' Spiral 🌱</a:t>
+            </a:r>
+            <a:endParaRPr lang="en-US" sz="6600" dirty="0"/>
+          </a:p>
+        </p:txBody>
+      </p:sp>
+      <p:sp>
+        <p:nvSpPr>
+          <p:cNvPr id="4" name="Text 5"/>
+          <p:cNvSpPr/>
+          <p:nvPr>
+            <p:ph idx="107" type="body" hasCustomPrompt="1"/>
+          </p:nvPr>
+        </p:nvSpPr>
+        <p:spPr>
+          <a:xfrm>
+            <a:off x="857250" y="3732276"/>
+            <a:ext cx="9715500" cy="411480"/>
+          </a:xfrm>
+          <a:prstGeom prst="rect">
+            <a:avLst/>
+          </a:prstGeom>
+          <a:noFill/>
+          <a:ln/>
+        </p:spPr>
+        <p:txBody>
+          <a:bodyPr wrap="square" lIns="0" tIns="0" rIns="0" bIns="0" rtlCol="0" anchor="ctr"/>
+          <a:lstStyle/>
+          <a:p>
+            <a:pPr algn="ctr" indent="0" marL="0">
+              <a:buNone/>
+            </a:pPr>
+            <a:r>
+              <a:rPr lang="en-US" sz="2250" dirty="0">
+                <a:solidFill>
+                  <a:srgbClr val="A8A49E"/>
+                </a:solidFill>
+                <a:latin typeface="Noto Sans JP" pitchFamily="34" charset="0"/>
+                <a:ea typeface="Noto Sans JP" pitchFamily="34" charset="-122"/>
+                <a:cs typeface="Noto Sans JP" pitchFamily="34" charset="-120"/>
+              </a:rPr>
+              <a:t>自分そのものから、人生と仕事を生きていく。</a:t>
+            </a:r>
+            <a:endParaRPr lang="en-US" sz="2250" dirty="0"/>
+          </a:p>
+        </p:txBody>
+      </p:sp>
+    </p:spTree>
+  </p:cSld>
+  <p:clrMapOvr>
+    <a:masterClrMapping/>
+  </p:clrMapOvr>
+</p:sld>
+</file>
+
+<file path=ppt/slides/slide15.xml><?xml version="1.0" encoding="utf-8"?>
+<p:sld xmlns:a="http://schemas.openxmlformats.org/drawingml/2006/main" xmlns:p="http://schemas.openxmlformats.org/presentationml/2006/main" xmlns:r="http://schemas.openxmlformats.org/officeDocument/2006/relationships">
+  <p:cSld name="dreamin-spiral-guide">
+    <p:spTree>
+      <p:nvGrpSpPr>
+        <p:cNvPr id="1" name=""/>
+        <p:cNvGrpSpPr/>
+        <p:nvPr/>
+      </p:nvGrpSpPr>
+      <p:grpSpPr/>
+      <p:sp>
+        <p:nvSpPr>
+          <p:cNvPr id="2" name="Text 5"/>
+          <p:cNvSpPr/>
+          <p:nvPr>
+            <p:ph idx="105" type="body" hasCustomPrompt="1"/>
+          </p:nvPr>
+        </p:nvSpPr>
+        <p:spPr>
+          <a:xfrm>
+            <a:off x="857250" y="1677924"/>
+            <a:ext cx="9715500" cy="256032"/>
+          </a:xfrm>
+          <a:prstGeom prst="rect">
+            <a:avLst/>
+          </a:prstGeom>
+          <a:noFill/>
+          <a:ln/>
+        </p:spPr>
+        <p:txBody>
+          <a:bodyPr wrap="square" lIns="0" tIns="0" rIns="0" bIns="0" rtlCol="0" anchor="ctr"/>
+          <a:lstStyle/>
+          <a:p>
+            <a:pPr algn="ctr" indent="0" marL="0">
+              <a:buNone/>
+            </a:pPr>
+            <a:r>
+              <a:rPr lang="en-US" sz="1200" spc="250" kern="0" dirty="0">
+                <a:solidFill>
+                  <a:srgbClr val="C0B8AD"/>
+                </a:solidFill>
+                <a:latin typeface="Noto Sans JP" pitchFamily="34" charset="0"/>
+                <a:ea typeface="Noto Sans JP" pitchFamily="34" charset="-122"/>
+                <a:cs typeface="Noto Sans JP" pitchFamily="34" charset="-120"/>
+              </a:rPr>
+              <a:t>DREAMIN' SPIRAL 🌱</a:t>
+            </a:r>
+            <a:endParaRPr lang="en-US" sz="1200" dirty="0"/>
+          </a:p>
+        </p:txBody>
+      </p:sp>
+      <p:sp>
+        <p:nvSpPr>
+          <p:cNvPr id="3" name="Text 5"/>
+          <p:cNvSpPr/>
+          <p:nvPr>
+            <p:ph idx="106" type="title" hasCustomPrompt="1"/>
+          </p:nvPr>
+        </p:nvSpPr>
+        <p:spPr>
+          <a:xfrm>
+            <a:off x="857250" y="2467356"/>
+            <a:ext cx="9715500" cy="960120"/>
+          </a:xfrm>
+          <a:prstGeom prst="rect">
+            <a:avLst/>
+          </a:prstGeom>
+          <a:noFill/>
+          <a:ln/>
+        </p:spPr>
+        <p:txBody>
+          <a:bodyPr wrap="square" lIns="0" tIns="0" rIns="0" bIns="0" rtlCol="0" anchor="ctr"/>
+          <a:lstStyle/>
+          <a:p>
+            <a:pPr algn="ctr" indent="0" marL="0">
+              <a:buNone/>
+            </a:pPr>
+            <a:r>
+              <a:rPr lang="en-US" sz="6600" dirty="0">
+                <a:solidFill>
+                  <a:srgbClr val="F7F6F4"/>
+                </a:solidFill>
+                <a:latin typeface="Noto Sans JP" pitchFamily="34" charset="0"/>
+                <a:ea typeface="Noto Sans JP" pitchFamily="34" charset="-122"/>
+                <a:cs typeface="Noto Sans JP" pitchFamily="34" charset="-120"/>
+              </a:rPr>
+              <a:t>Guide</a:t>
+            </a:r>
+            <a:endParaRPr lang="en-US" sz="6600" dirty="0"/>
+          </a:p>
+        </p:txBody>
+      </p:sp>
+      <p:sp>
+        <p:nvSpPr>
+          <p:cNvPr id="4" name="Text 5"/>
+          <p:cNvSpPr/>
+          <p:nvPr>
+            <p:ph idx="107" type="body" hasCustomPrompt="1"/>
+          </p:nvPr>
+        </p:nvSpPr>
+        <p:spPr>
+          <a:xfrm>
+            <a:off x="857250" y="3732276"/>
+            <a:ext cx="9715500" cy="411480"/>
+          </a:xfrm>
+          <a:prstGeom prst="rect">
+            <a:avLst/>
+          </a:prstGeom>
+          <a:noFill/>
+          <a:ln/>
+        </p:spPr>
+        <p:txBody>
+          <a:bodyPr wrap="square" lIns="0" tIns="0" rIns="0" bIns="0" rtlCol="0" anchor="ctr"/>
+          <a:lstStyle/>
+          <a:p>
+            <a:pPr algn="ctr" indent="0" marL="0">
+              <a:buNone/>
+            </a:pPr>
+            <a:r>
+              <a:rPr lang="en-US" sz="2250" dirty="0">
+                <a:solidFill>
+                  <a:srgbClr val="A8A49E"/>
+                </a:solidFill>
+                <a:latin typeface="Noto Sans JP" pitchFamily="34" charset="0"/>
+                <a:ea typeface="Noto Sans JP" pitchFamily="34" charset="-122"/>
+                <a:cs typeface="Noto Sans JP" pitchFamily="34" charset="-120"/>
+              </a:rPr>
+              <a:t>今、気になっていることを話してみたい人へ。</a:t>
+            </a:r>
+            <a:endParaRPr lang="en-US" sz="2250" dirty="0"/>
+          </a:p>
+        </p:txBody>
+      </p:sp>
+    </p:spTree>
+  </p:cSld>
+  <p:clrMapOvr>
+    <a:masterClrMapping/>
+  </p:clrMapOvr>
+</p:sld>
+</file>
+
+<file path=ppt/slides/slide16.xml><?xml version="1.0" encoding="utf-8"?>
+<p:sld xmlns:a="http://schemas.openxmlformats.org/drawingml/2006/main" xmlns:p="http://schemas.openxmlformats.org/presentationml/2006/main" xmlns:r="http://schemas.openxmlformats.org/officeDocument/2006/relationships">
+  <p:cSld name="dreamin-spiral-3-weeks">
+    <p:spTree>
+      <p:nvGrpSpPr>
+        <p:cNvPr id="1" name=""/>
+        <p:cNvGrpSpPr/>
+        <p:nvPr/>
+      </p:nvGrpSpPr>
+      <p:grpSpPr/>
+      <p:sp>
+        <p:nvSpPr>
+          <p:cNvPr id="2" name="Text 5"/>
+          <p:cNvSpPr/>
+          <p:nvPr>
+            <p:ph idx="105" type="body" hasCustomPrompt="1"/>
+          </p:nvPr>
+        </p:nvSpPr>
+        <p:spPr>
+          <a:xfrm>
+            <a:off x="857250" y="1677924"/>
+            <a:ext cx="9715500" cy="256032"/>
+          </a:xfrm>
+          <a:prstGeom prst="rect">
+            <a:avLst/>
+          </a:prstGeom>
+          <a:noFill/>
+          <a:ln/>
+        </p:spPr>
+        <p:txBody>
+          <a:bodyPr wrap="square" lIns="0" tIns="0" rIns="0" bIns="0" rtlCol="0" anchor="ctr"/>
+          <a:lstStyle/>
+          <a:p>
+            <a:pPr algn="ctr" indent="0" marL="0">
+              <a:buNone/>
+            </a:pPr>
+            <a:r>
+              <a:rPr lang="en-US" sz="1200" spc="250" kern="0" dirty="0">
+                <a:solidFill>
+                  <a:srgbClr val="C0B8AD"/>
+                </a:solidFill>
+                <a:latin typeface="Noto Sans JP" pitchFamily="34" charset="0"/>
+                <a:ea typeface="Noto Sans JP" pitchFamily="34" charset="-122"/>
+                <a:cs typeface="Noto Sans JP" pitchFamily="34" charset="-120"/>
+              </a:rPr>
+              <a:t>DREAMIN' SPIRAL 🌱</a:t>
+            </a:r>
+            <a:endParaRPr lang="en-US" sz="1200" dirty="0"/>
+          </a:p>
+        </p:txBody>
+      </p:sp>
+      <p:sp>
+        <p:nvSpPr>
+          <p:cNvPr id="3" name="Text 5"/>
+          <p:cNvSpPr/>
+          <p:nvPr>
+            <p:ph idx="106" type="title" hasCustomPrompt="1"/>
+          </p:nvPr>
+        </p:nvSpPr>
+        <p:spPr>
+          <a:xfrm>
+            <a:off x="857250" y="2467356"/>
+            <a:ext cx="9715500" cy="960120"/>
+          </a:xfrm>
+          <a:prstGeom prst="rect">
+            <a:avLst/>
+          </a:prstGeom>
+          <a:noFill/>
+          <a:ln/>
+        </p:spPr>
+        <p:txBody>
+          <a:bodyPr wrap="square" lIns="0" tIns="0" rIns="0" bIns="0" rtlCol="0" anchor="ctr"/>
+          <a:lstStyle/>
+          <a:p>
+            <a:pPr algn="ctr" indent="0" marL="0">
+              <a:buNone/>
+            </a:pPr>
+            <a:r>
+              <a:rPr lang="en-US" sz="6600" dirty="0">
+                <a:solidFill>
+                  <a:srgbClr val="F7F6F4"/>
+                </a:solidFill>
+                <a:latin typeface="Noto Sans JP" pitchFamily="34" charset="0"/>
+                <a:ea typeface="Noto Sans JP" pitchFamily="34" charset="-122"/>
+                <a:cs typeface="Noto Sans JP" pitchFamily="34" charset="-120"/>
+              </a:rPr>
+              <a:t>3 Weeks Tuning</a:t>
+            </a:r>
+            <a:endParaRPr lang="en-US" sz="6600" dirty="0"/>
+          </a:p>
+        </p:txBody>
+      </p:sp>
+      <p:sp>
+        <p:nvSpPr>
+          <p:cNvPr id="4" name="Text 5"/>
+          <p:cNvSpPr/>
+          <p:nvPr>
+            <p:ph idx="107" type="body" hasCustomPrompt="1"/>
+          </p:nvPr>
+        </p:nvSpPr>
+        <p:spPr>
+          <a:xfrm>
+            <a:off x="857250" y="3732276"/>
+            <a:ext cx="9715500" cy="411480"/>
+          </a:xfrm>
+          <a:prstGeom prst="rect">
+            <a:avLst/>
+          </a:prstGeom>
+          <a:noFill/>
+          <a:ln/>
+        </p:spPr>
+        <p:txBody>
+          <a:bodyPr wrap="square" lIns="0" tIns="0" rIns="0" bIns="0" rtlCol="0" anchor="ctr"/>
+          <a:lstStyle/>
+          <a:p>
+            <a:pPr algn="ctr" indent="0" marL="0">
+              <a:buNone/>
+            </a:pPr>
+            <a:r>
+              <a:rPr lang="en-US" sz="2250" dirty="0">
+                <a:solidFill>
+                  <a:srgbClr val="A8A49E"/>
+                </a:solidFill>
+                <a:latin typeface="Noto Sans JP" pitchFamily="34" charset="0"/>
+                <a:ea typeface="Noto Sans JP" pitchFamily="34" charset="-122"/>
+                <a:cs typeface="Noto Sans JP" pitchFamily="34" charset="-120"/>
+              </a:rPr>
+              <a:t>「気になる」や「悩み」から、</a:t>
+            </a:r>
+            <a:br/>
+            <a:endParaRPr lang="en-US" sz="2250" dirty="0"/>
+            <a:r>
+              <a:rPr lang="en-US" sz="2250" dirty="0">
+                <a:solidFill>
+                  <a:srgbClr val="A8A49E"/>
+                </a:solidFill>
+                <a:latin typeface="Noto Sans JP" pitchFamily="34" charset="0"/>
+                <a:ea typeface="Noto Sans JP" pitchFamily="34" charset="-122"/>
+                <a:cs typeface="Noto Sans JP" pitchFamily="34" charset="-120"/>
+              </a:rPr>
+              <a:t>3週間かけて自分そのものに気づいていく人へ。</a:t>
+            </a:r>
+          </a:p>
+        </p:txBody>
+      </p:sp>
+    </p:spTree>
+  </p:cSld>
+  <p:clrMapOvr>
+    <a:masterClrMapping/>
+  </p:clrMapOvr>
+</p:sld>
+</file>
+
+<file path=ppt/slides/slide17.xml><?xml version="1.0" encoding="utf-8"?>
+<p:sld xmlns:a="http://schemas.openxmlformats.org/drawingml/2006/main" xmlns:p="http://schemas.openxmlformats.org/presentationml/2006/main" xmlns:r="http://schemas.openxmlformats.org/officeDocument/2006/relationships">
+  <p:cSld name="dreamin-spiral-community">
+    <p:spTree>
+      <p:nvGrpSpPr>
+        <p:cNvPr id="1" name=""/>
+        <p:cNvGrpSpPr/>
+        <p:nvPr/>
+      </p:nvGrpSpPr>
+      <p:grpSpPr/>
+      <p:sp>
+        <p:nvSpPr>
+          <p:cNvPr id="2" name="Text 5"/>
+          <p:cNvSpPr/>
+          <p:nvPr>
+            <p:ph idx="105" type="body" hasCustomPrompt="1"/>
+          </p:nvPr>
+        </p:nvSpPr>
+        <p:spPr>
+          <a:xfrm>
+            <a:off x="857250" y="1677924"/>
+            <a:ext cx="9715500" cy="256032"/>
+          </a:xfrm>
+          <a:prstGeom prst="rect">
+            <a:avLst/>
+          </a:prstGeom>
+          <a:noFill/>
+          <a:ln/>
+        </p:spPr>
+        <p:txBody>
+          <a:bodyPr wrap="square" lIns="0" tIns="0" rIns="0" bIns="0" rtlCol="0" anchor="ctr"/>
+          <a:lstStyle/>
+          <a:p>
+            <a:pPr algn="ctr" indent="0" marL="0">
+              <a:buNone/>
+            </a:pPr>
+            <a:r>
+              <a:rPr lang="en-US" sz="1200" spc="250" kern="0" dirty="0">
+                <a:solidFill>
+                  <a:srgbClr val="C0B8AD"/>
+                </a:solidFill>
+                <a:latin typeface="Noto Sans JP" pitchFamily="34" charset="0"/>
+                <a:ea typeface="Noto Sans JP" pitchFamily="34" charset="-122"/>
+                <a:cs typeface="Noto Sans JP" pitchFamily="34" charset="-120"/>
+              </a:rPr>
+              <a:t>DREAMIN' SPIRAL 🌱</a:t>
+            </a:r>
+            <a:endParaRPr lang="en-US" sz="1200" dirty="0"/>
+          </a:p>
+        </p:txBody>
+      </p:sp>
+      <p:sp>
+        <p:nvSpPr>
+          <p:cNvPr id="3" name="Text 5"/>
+          <p:cNvSpPr/>
+          <p:nvPr>
+            <p:ph idx="106" type="title" hasCustomPrompt="1"/>
+          </p:nvPr>
+        </p:nvSpPr>
+        <p:spPr>
+          <a:xfrm>
+            <a:off x="857250" y="2467356"/>
+            <a:ext cx="9715500" cy="960120"/>
+          </a:xfrm>
+          <a:prstGeom prst="rect">
+            <a:avLst/>
+          </a:prstGeom>
+          <a:noFill/>
+          <a:ln/>
+        </p:spPr>
+        <p:txBody>
+          <a:bodyPr wrap="square" lIns="0" tIns="0" rIns="0" bIns="0" rtlCol="0" anchor="ctr"/>
+          <a:lstStyle/>
+          <a:p>
+            <a:pPr algn="ctr" indent="0" marL="0">
+              <a:buNone/>
+            </a:pPr>
+            <a:r>
+              <a:rPr lang="en-US" sz="6600" dirty="0">
+                <a:solidFill>
+                  <a:srgbClr val="F7F6F4"/>
+                </a:solidFill>
+                <a:latin typeface="Noto Sans JP" pitchFamily="34" charset="0"/>
+                <a:ea typeface="Noto Sans JP" pitchFamily="34" charset="-122"/>
+                <a:cs typeface="Noto Sans JP" pitchFamily="34" charset="-120"/>
+              </a:rPr>
+              <a:t>Community</a:t>
+            </a:r>
+            <a:endParaRPr lang="en-US" sz="6600" dirty="0"/>
+          </a:p>
+        </p:txBody>
+      </p:sp>
+      <p:sp>
+        <p:nvSpPr>
+          <p:cNvPr id="4" name="Text 5"/>
+          <p:cNvSpPr/>
+          <p:nvPr>
+            <p:ph idx="107" type="body" hasCustomPrompt="1"/>
+          </p:nvPr>
+        </p:nvSpPr>
+        <p:spPr>
+          <a:xfrm>
+            <a:off x="857250" y="3732276"/>
+            <a:ext cx="9715500" cy="411480"/>
+          </a:xfrm>
+          <a:prstGeom prst="rect">
+            <a:avLst/>
+          </a:prstGeom>
+          <a:noFill/>
+          <a:ln/>
+        </p:spPr>
+        <p:txBody>
+          <a:bodyPr wrap="square" lIns="0" tIns="0" rIns="0" bIns="0" rtlCol="0" anchor="ctr"/>
+          <a:lstStyle/>
+          <a:p>
+            <a:pPr algn="ctr" indent="0" marL="0">
+              <a:buNone/>
+            </a:pPr>
+            <a:r>
+              <a:rPr lang="en-US" sz="2250" dirty="0">
+                <a:solidFill>
+                  <a:srgbClr val="A8A49E"/>
+                </a:solidFill>
+                <a:latin typeface="Noto Sans JP" pitchFamily="34" charset="0"/>
+                <a:ea typeface="Noto Sans JP" pitchFamily="34" charset="-122"/>
+                <a:cs typeface="Noto Sans JP" pitchFamily="34" charset="-120"/>
+              </a:rPr>
+              <a:t>人とつながりながら、</a:t>
+            </a:r>
+            <a:br/>
+            <a:endParaRPr lang="en-US" sz="2250" dirty="0"/>
+            <a:r>
+              <a:rPr lang="en-US" sz="2250" dirty="0">
+                <a:solidFill>
+                  <a:srgbClr val="A8A49E"/>
+                </a:solidFill>
+                <a:latin typeface="Noto Sans JP" pitchFamily="34" charset="0"/>
+                <a:ea typeface="Noto Sans JP" pitchFamily="34" charset="-122"/>
+                <a:cs typeface="Noto Sans JP" pitchFamily="34" charset="-120"/>
+              </a:rPr>
+              <a:t>日々の中で自分に気づき続けていける人へ。</a:t>
+            </a:r>
+          </a:p>
+        </p:txBody>
+      </p:sp>
+    </p:spTree>
+  </p:cSld>
+  <p:clrMapOvr>
+    <a:masterClrMapping/>
+  </p:clrMapOvr>
+</p:sld>
+</file>
+
+<file path=ppt/slides/slide18.xml><?xml version="1.0" encoding="utf-8"?>
+<p:sld xmlns:a="http://schemas.openxmlformats.org/drawingml/2006/main" xmlns:p="http://schemas.openxmlformats.org/presentationml/2006/main" xmlns:r="http://schemas.openxmlformats.org/officeDocument/2006/relationships">
+  <p:cSld name="dreamin-spiral-my-life">
+    <p:spTree>
+      <p:nvGrpSpPr>
+        <p:cNvPr id="1" name=""/>
+        <p:cNvGrpSpPr/>
+        <p:nvPr/>
+      </p:nvGrpSpPr>
+      <p:grpSpPr/>
+      <p:sp>
+        <p:nvSpPr>
+          <p:cNvPr id="2" name="Text 5"/>
+          <p:cNvSpPr/>
+          <p:nvPr>
+            <p:ph idx="105" type="body" hasCustomPrompt="1"/>
+          </p:nvPr>
+        </p:nvSpPr>
+        <p:spPr>
+          <a:xfrm>
+            <a:off x="857250" y="1677924"/>
+            <a:ext cx="9715500" cy="256032"/>
+          </a:xfrm>
+          <a:prstGeom prst="rect">
+            <a:avLst/>
+          </a:prstGeom>
+          <a:noFill/>
+          <a:ln/>
+        </p:spPr>
+        <p:txBody>
+          <a:bodyPr wrap="square" lIns="0" tIns="0" rIns="0" bIns="0" rtlCol="0" anchor="ctr"/>
+          <a:lstStyle/>
+          <a:p>
+            <a:pPr algn="ctr" indent="0" marL="0">
+              <a:buNone/>
+            </a:pPr>
+            <a:r>
+              <a:rPr lang="en-US" sz="1200" spc="250" kern="0" dirty="0">
+                <a:solidFill>
+                  <a:srgbClr val="C0B8AD"/>
+                </a:solidFill>
+                <a:latin typeface="Noto Sans JP" pitchFamily="34" charset="0"/>
+                <a:ea typeface="Noto Sans JP" pitchFamily="34" charset="-122"/>
+                <a:cs typeface="Noto Sans JP" pitchFamily="34" charset="-120"/>
+              </a:rPr>
+              <a:t>DREAMIN' SPIRAL 🌱</a:t>
+            </a:r>
+            <a:endParaRPr lang="en-US" sz="1200" dirty="0"/>
+          </a:p>
+        </p:txBody>
+      </p:sp>
+      <p:sp>
+        <p:nvSpPr>
+          <p:cNvPr id="3" name="Text 5"/>
+          <p:cNvSpPr/>
+          <p:nvPr>
+            <p:ph idx="106" type="title" hasCustomPrompt="1"/>
+          </p:nvPr>
+        </p:nvSpPr>
+        <p:spPr>
+          <a:xfrm>
+            <a:off x="857250" y="2467356"/>
+            <a:ext cx="9715500" cy="960120"/>
+          </a:xfrm>
+          <a:prstGeom prst="rect">
+            <a:avLst/>
+          </a:prstGeom>
+          <a:noFill/>
+          <a:ln/>
+        </p:spPr>
+        <p:txBody>
+          <a:bodyPr wrap="square" lIns="0" tIns="0" rIns="0" bIns="0" rtlCol="0" anchor="ctr"/>
+          <a:lstStyle/>
+          <a:p>
+            <a:pPr algn="ctr" indent="0" marL="0">
+              <a:buNone/>
+            </a:pPr>
+            <a:r>
+              <a:rPr lang="en-US" sz="6600" dirty="0">
+                <a:solidFill>
+                  <a:srgbClr val="F7F6F4"/>
+                </a:solidFill>
+                <a:latin typeface="Noto Sans JP" pitchFamily="34" charset="0"/>
+                <a:ea typeface="Noto Sans JP" pitchFamily="34" charset="-122"/>
+                <a:cs typeface="Noto Sans JP" pitchFamily="34" charset="-120"/>
+              </a:rPr>
+              <a:t>My Life, My Way</a:t>
+            </a:r>
+            <a:endParaRPr lang="en-US" sz="6600" dirty="0"/>
+          </a:p>
+        </p:txBody>
+      </p:sp>
+      <p:sp>
+        <p:nvSpPr>
+          <p:cNvPr id="4" name="Text 5"/>
+          <p:cNvSpPr/>
+          <p:nvPr>
+            <p:ph idx="107" type="body" hasCustomPrompt="1"/>
+          </p:nvPr>
+        </p:nvSpPr>
+        <p:spPr>
+          <a:xfrm>
+            <a:off x="857250" y="3732276"/>
+            <a:ext cx="9715500" cy="411480"/>
+          </a:xfrm>
+          <a:prstGeom prst="rect">
+            <a:avLst/>
+          </a:prstGeom>
+          <a:noFill/>
+          <a:ln/>
+        </p:spPr>
+        <p:txBody>
+          <a:bodyPr wrap="square" lIns="0" tIns="0" rIns="0" bIns="0" rtlCol="0" anchor="ctr"/>
+          <a:lstStyle/>
+          <a:p>
+            <a:pPr algn="ctr" indent="0" marL="0">
+              <a:buNone/>
+            </a:pPr>
+            <a:r>
+              <a:rPr lang="en-US" sz="2250" dirty="0">
+                <a:solidFill>
+                  <a:srgbClr val="A8A49E"/>
+                </a:solidFill>
+                <a:latin typeface="Noto Sans JP" pitchFamily="34" charset="0"/>
+                <a:ea typeface="Noto Sans JP" pitchFamily="34" charset="-122"/>
+                <a:cs typeface="Noto Sans JP" pitchFamily="34" charset="-120"/>
+              </a:rPr>
+              <a:t>自分の気持ちや望みに気づきながら、</a:t>
+            </a:r>
+            <a:br/>
+            <a:endParaRPr lang="en-US" sz="2250" dirty="0"/>
+            <a:r>
+              <a:rPr lang="en-US" sz="2250" dirty="0">
+                <a:solidFill>
+                  <a:srgbClr val="A8A49E"/>
+                </a:solidFill>
+                <a:latin typeface="Noto Sans JP" pitchFamily="34" charset="0"/>
+                <a:ea typeface="Noto Sans JP" pitchFamily="34" charset="-122"/>
+                <a:cs typeface="Noto Sans JP" pitchFamily="34" charset="-120"/>
+              </a:rPr>
+              <a:t>自分の人生を、自分で選んで生きていく人へ。</a:t>
+            </a:r>
+          </a:p>
+        </p:txBody>
+      </p:sp>
+    </p:spTree>
+  </p:cSld>
+  <p:clrMapOvr>
+    <a:masterClrMapping/>
+  </p:clrMapOvr>
+</p:sld>
+</file>
+
+<file path=ppt/slides/slide19.xml><?xml version="1.0" encoding="utf-8"?>
+<p:sld xmlns:a="http://schemas.openxmlformats.org/drawingml/2006/main" xmlns:p="http://schemas.openxmlformats.org/presentationml/2006/main" xmlns:r="http://schemas.openxmlformats.org/officeDocument/2006/relationships">
+  <p:cSld name="dreamin-spiral-project-creation">
+    <p:spTree>
+      <p:nvGrpSpPr>
+        <p:cNvPr id="1" name=""/>
+        <p:cNvGrpSpPr/>
+        <p:nvPr/>
+      </p:nvGrpSpPr>
+      <p:grpSpPr/>
+      <p:sp>
+        <p:nvSpPr>
+          <p:cNvPr id="2" name="Text 5"/>
+          <p:cNvSpPr/>
+          <p:nvPr>
+            <p:ph idx="105" type="body" hasCustomPrompt="1"/>
+          </p:nvPr>
+        </p:nvSpPr>
+        <p:spPr>
+          <a:xfrm>
+            <a:off x="857250" y="1677924"/>
+            <a:ext cx="9715500" cy="256032"/>
+          </a:xfrm>
+          <a:prstGeom prst="rect">
+            <a:avLst/>
+          </a:prstGeom>
+          <a:noFill/>
+          <a:ln/>
+        </p:spPr>
+        <p:txBody>
+          <a:bodyPr wrap="square" lIns="0" tIns="0" rIns="0" bIns="0" rtlCol="0" anchor="ctr"/>
+          <a:lstStyle/>
+          <a:p>
+            <a:pPr algn="ctr" indent="0" marL="0">
+              <a:buNone/>
+            </a:pPr>
+            <a:r>
+              <a:rPr lang="en-US" sz="1200" spc="250" kern="0" dirty="0">
+                <a:solidFill>
+                  <a:srgbClr val="C0B8AD"/>
+                </a:solidFill>
+                <a:latin typeface="Noto Sans JP" pitchFamily="34" charset="0"/>
+                <a:ea typeface="Noto Sans JP" pitchFamily="34" charset="-122"/>
+                <a:cs typeface="Noto Sans JP" pitchFamily="34" charset="-120"/>
+              </a:rPr>
+              <a:t>DREAMIN' SPIRAL 🌱</a:t>
+            </a:r>
+            <a:endParaRPr lang="en-US" sz="1200" dirty="0"/>
+          </a:p>
+        </p:txBody>
+      </p:sp>
+      <p:sp>
+        <p:nvSpPr>
+          <p:cNvPr id="3" name="Text 5"/>
+          <p:cNvSpPr/>
+          <p:nvPr>
+            <p:ph idx="106" type="title" hasCustomPrompt="1"/>
+          </p:nvPr>
+        </p:nvSpPr>
+        <p:spPr>
+          <a:xfrm>
+            <a:off x="857250" y="2467356"/>
+            <a:ext cx="9715500" cy="960120"/>
+          </a:xfrm>
+          <a:prstGeom prst="rect">
+            <a:avLst/>
+          </a:prstGeom>
+          <a:noFill/>
+          <a:ln/>
+        </p:spPr>
+        <p:txBody>
+          <a:bodyPr wrap="square" lIns="0" tIns="0" rIns="0" bIns="0" rtlCol="0" anchor="ctr"/>
+          <a:lstStyle/>
+          <a:p>
+            <a:pPr algn="ctr" indent="0" marL="0">
+              <a:buNone/>
+            </a:pPr>
+            <a:r>
+              <a:rPr lang="en-US" sz="6600" dirty="0">
+                <a:solidFill>
+                  <a:srgbClr val="F7F6F4"/>
+                </a:solidFill>
+                <a:latin typeface="Noto Sans JP" pitchFamily="34" charset="0"/>
+                <a:ea typeface="Noto Sans JP" pitchFamily="34" charset="-122"/>
+                <a:cs typeface="Noto Sans JP" pitchFamily="34" charset="-120"/>
+              </a:rPr>
+              <a:t>Project Creation</a:t>
+            </a:r>
+            <a:endParaRPr lang="en-US" sz="6600" dirty="0"/>
+          </a:p>
+        </p:txBody>
+      </p:sp>
+      <p:sp>
+        <p:nvSpPr>
+          <p:cNvPr id="4" name="Text 5"/>
+          <p:cNvSpPr/>
+          <p:nvPr>
+            <p:ph idx="107" type="body" hasCustomPrompt="1"/>
+          </p:nvPr>
+        </p:nvSpPr>
+        <p:spPr>
+          <a:xfrm>
+            <a:off x="857250" y="3732276"/>
+            <a:ext cx="9715500" cy="411480"/>
+          </a:xfrm>
+          <a:prstGeom prst="rect">
+            <a:avLst/>
+          </a:prstGeom>
+          <a:noFill/>
+          <a:ln/>
+        </p:spPr>
+        <p:txBody>
+          <a:bodyPr wrap="square" lIns="0" tIns="0" rIns="0" bIns="0" rtlCol="0" anchor="ctr"/>
+          <a:lstStyle/>
+          <a:p>
+            <a:pPr algn="ctr" indent="0" marL="0">
+              <a:buNone/>
+            </a:pPr>
+            <a:r>
+              <a:rPr lang="en-US" sz="2250" dirty="0">
+                <a:solidFill>
+                  <a:srgbClr val="A8A49E"/>
+                </a:solidFill>
+                <a:latin typeface="Noto Sans JP" pitchFamily="34" charset="0"/>
+                <a:ea typeface="Noto Sans JP" pitchFamily="34" charset="-122"/>
+                <a:cs typeface="Noto Sans JP" pitchFamily="34" charset="-120"/>
+              </a:rPr>
+              <a:t>エンジニアから、プロジェクトを創る人へ。</a:t>
+            </a:r>
+            <a:endParaRPr lang="en-US" sz="2250" dirty="0"/>
+          </a:p>
+        </p:txBody>
+      </p:sp>
+    </p:spTree>
+  </p:cSld>
+  <p:clrMapOvr>
+    <a:masterClrMapping/>
+  </p:clrMapOvr>
+</p:sld>
+</file>
+
 <file path=ppt/slides/slide2.xml><?xml version="1.0" encoding="utf-8"?>
 <p:sld xmlns:a="http://schemas.openxmlformats.org/drawingml/2006/main" xmlns:r="http://schemas.openxmlformats.org/officeDocument/2006/relationships" xmlns:p="http://schemas.openxmlformats.org/presentationml/2006/main">
   <p:cSld name="top">
@@ -3039,6 +3928,159 @@
               <a:t>変容には、外側と内側がある。</a:t>
             </a:r>
             <a:endParaRPr lang="en-US" sz="2250" dirty="0"/>
+          </a:p>
+        </p:txBody>
+      </p:sp>
+    </p:spTree>
+  </p:cSld>
+  <p:clrMapOvr>
+    <a:masterClrMapping/>
+  </p:clrMapOvr>
+</p:sld>
+</file>
+
+<file path=ppt/slides/slide20.xml><?xml version="1.0" encoding="utf-8"?>
+<p:sld xmlns:a="http://schemas.openxmlformats.org/drawingml/2006/main" xmlns:p="http://schemas.openxmlformats.org/presentationml/2006/main" xmlns:r="http://schemas.openxmlformats.org/officeDocument/2006/relationships">
+  <p:cSld name="dreamin-spiral-business-creation">
+    <p:spTree>
+      <p:nvGrpSpPr>
+        <p:cNvPr id="1" name=""/>
+        <p:cNvGrpSpPr/>
+        <p:nvPr/>
+      </p:nvGrpSpPr>
+      <p:grpSpPr/>
+      <p:sp>
+        <p:nvSpPr>
+          <p:cNvPr id="2" name="Text 5"/>
+          <p:cNvSpPr/>
+          <p:nvPr>
+            <p:ph idx="105" type="body" hasCustomPrompt="1"/>
+          </p:nvPr>
+        </p:nvSpPr>
+        <p:spPr>
+          <a:xfrm>
+            <a:off x="857250" y="1677924"/>
+            <a:ext cx="9715500" cy="256032"/>
+          </a:xfrm>
+          <a:prstGeom prst="rect">
+            <a:avLst/>
+          </a:prstGeom>
+          <a:noFill/>
+          <a:ln/>
+        </p:spPr>
+        <p:txBody>
+          <a:bodyPr wrap="square" lIns="0" tIns="0" rIns="0" bIns="0" rtlCol="0" anchor="ctr"/>
+          <a:lstStyle/>
+          <a:p>
+            <a:pPr algn="ctr" indent="0" marL="0">
+              <a:buNone/>
+            </a:pPr>
+            <a:r>
+              <a:rPr lang="en-US" sz="1200" spc="250" kern="0" dirty="0">
+                <a:solidFill>
+                  <a:srgbClr val="C0B8AD"/>
+                </a:solidFill>
+                <a:latin typeface="Noto Sans JP" pitchFamily="34" charset="0"/>
+                <a:ea typeface="Noto Sans JP" pitchFamily="34" charset="-122"/>
+                <a:cs typeface="Noto Sans JP" pitchFamily="34" charset="-120"/>
+              </a:rPr>
+              <a:t>DREAMIN' SPIRAL 🌱</a:t>
+            </a:r>
+            <a:endParaRPr lang="en-US" sz="1200" dirty="0"/>
+          </a:p>
+        </p:txBody>
+      </p:sp>
+      <p:sp>
+        <p:nvSpPr>
+          <p:cNvPr id="3" name="Text 5"/>
+          <p:cNvSpPr/>
+          <p:nvPr>
+            <p:ph idx="106" type="title" hasCustomPrompt="1"/>
+          </p:nvPr>
+        </p:nvSpPr>
+        <p:spPr>
+          <a:xfrm>
+            <a:off x="857250" y="2467356"/>
+            <a:ext cx="9715500" cy="960120"/>
+          </a:xfrm>
+          <a:prstGeom prst="rect">
+            <a:avLst/>
+          </a:prstGeom>
+          <a:noFill/>
+          <a:ln/>
+        </p:spPr>
+        <p:txBody>
+          <a:bodyPr wrap="square" lIns="0" tIns="0" rIns="0" bIns="0" rtlCol="0" anchor="ctr"/>
+          <a:lstStyle/>
+          <a:p>
+            <a:pPr algn="ctr" indent="0" marL="0">
+              <a:buNone/>
+            </a:pPr>
+            <a:r>
+              <a:rPr lang="en-US" sz="6600" dirty="0">
+                <a:solidFill>
+                  <a:srgbClr val="F7F6F4"/>
+                </a:solidFill>
+                <a:latin typeface="Noto Sans JP" pitchFamily="34" charset="0"/>
+                <a:ea typeface="Noto Sans JP" pitchFamily="34" charset="-122"/>
+                <a:cs typeface="Noto Sans JP" pitchFamily="34" charset="-120"/>
+              </a:rPr>
+              <a:t>Business Creation</a:t>
+            </a:r>
+            <a:endParaRPr lang="en-US" sz="6600" dirty="0"/>
+          </a:p>
+        </p:txBody>
+      </p:sp>
+      <p:sp>
+        <p:nvSpPr>
+          <p:cNvPr id="4" name="Text 5"/>
+          <p:cNvSpPr/>
+          <p:nvPr>
+            <p:ph idx="107" type="body" hasCustomPrompt="1"/>
+          </p:nvPr>
+        </p:nvSpPr>
+        <p:spPr>
+          <a:xfrm>
+            <a:off x="857250" y="3732276"/>
+            <a:ext cx="9715500" cy="411480"/>
+          </a:xfrm>
+          <a:prstGeom prst="rect">
+            <a:avLst/>
+          </a:prstGeom>
+          <a:noFill/>
+          <a:ln/>
+        </p:spPr>
+        <p:txBody>
+          <a:bodyPr wrap="square" lIns="0" tIns="0" rIns="0" bIns="0" rtlCol="0" anchor="ctr"/>
+          <a:lstStyle/>
+          <a:p>
+            <a:pPr algn="ctr" indent="0" marL="0">
+              <a:buNone/>
+            </a:pPr>
+            <a:r>
+              <a:rPr lang="en-US" sz="2250" dirty="0">
+                <a:solidFill>
+                  <a:srgbClr val="A8A49E"/>
+                </a:solidFill>
+                <a:latin typeface="Noto Sans JP" pitchFamily="34" charset="0"/>
+                <a:ea typeface="Noto Sans JP" pitchFamily="34" charset="-122"/>
+                <a:cs typeface="Noto Sans JP" pitchFamily="34" charset="-120"/>
+              </a:rPr>
+              <a:t>自分の経験や想いを、Businessとして形にし、</a:t>
+            </a:r>
+            <a:br/>
+            <a:endParaRPr lang="en-US" sz="2250" dirty="0"/>
+            <a:r>
+              <a:rPr lang="en-US" sz="2250" dirty="0">
+                <a:solidFill>
+                  <a:srgbClr val="A8A49E"/>
+                </a:solidFill>
+                <a:latin typeface="Noto Sans JP" pitchFamily="34" charset="0"/>
+                <a:ea typeface="Noto Sans JP" pitchFamily="34" charset="-122"/>
+                <a:cs typeface="Noto Sans JP" pitchFamily="34" charset="-120"/>
+              </a:rPr>
+              <a:t>実際に届けながら育てていく人へ。</a:t>
+            </a:r>
           </a:p>
         </p:txBody>
       </p:sp>

</xml_diff>